<commit_message>
Refine Section 2.2 presentation insights and outputs
</commit_message>
<xml_diff>
--- a/Section_2.2_应用现状综述_汇报版.pptx
+++ b/Section_2.2_应用现状综述_汇报版.pptx
@@ -156,7 +156,7 @@
     </p:spTree>
     <p:extLst>
       <p:ext uri="{BB962C8B-B14F-4D97-AF65-F5344CB8AC3E}">
-        <p14:creationId xmlns:p14="http://schemas.microsoft.com/office/powerpoint/2010/main" val="1174188937"/>
+        <p14:creationId xmlns:p14="http://schemas.microsoft.com/office/powerpoint/2010/main" val="3200115174"/>
       </p:ext>
     </p:extLst>
   </p:cSld>
@@ -371,7 +371,7 @@
           <a:lstStyle/>
           <a:p>
             <a:r>
-              <a:t>这张图的重点不是谁最大，而是谁开始变得更复杂、更可复制。助学规模最大，但助教、助评、助育这些场景的扩散广度正在抬升，说明 AI 应用正从单一学生支持转向教学、评价和治理的多支点演化。</a:t>
+              <a:t>这张图最值得讲的，不是 助学 最大，而是它虽然占了 72.1%，却已经不能代表全部趋势。前两大场景合计 90.0%，说明行业正在出现主航道；与此同时，助评、助育等更复杂场景在覆盖广度上抬升，说明 AI 教育应用开始从学生支持走向教学系统深处。</a:t>
             </a:r>
           </a:p>
         </p:txBody>
@@ -441,7 +441,7 @@
           <a:lstStyle/>
           <a:p>
             <a:r>
-              <a:t>看区域时不能只看东部有多少案例，更要看东部内部是不是已经形成更丰富的场景组合。标准化之后可以看到，东部在助教、助评、助育等结构性场景中的权重更高，而中西部更依赖少数高频通用场景，这就是当前真正的区域分化。</a:t>
+              <a:t>这一页要讲清三层意思。第一，浙江省、四川省、重庆市和北京市四省市合计占比达到54.1%，头部区域板块已经成形。第二，东部不只是案例多，而是豆包（250次）、DeepSeek 大模型（179次）、即梦AI（103次）形成了更高阶的组合结构；第三，中部更像平台化推进，西部更像头部产品导入期。所以区域差异的本质不是有没有接入 AI，而是谁先形成了稳定、可复制、可扩展的产品组合。</a:t>
             </a:r>
           </a:p>
         </p:txBody>
@@ -511,7 +511,7 @@
           <a:lstStyle/>
           <a:p>
             <a:r>
-              <a:t>这一页强调的是场景依附关系。比如助学为什么更集中在小学，不只是因为小学案例多，而是因为小学更适合把模型嵌入到情境化教学和即时反馈里。而助评、助育等场景的学段依赖更集中，说明这些场景还没有进入真正的泛化阶段。</a:t>
+              <a:t>这一页强调的不是哪个学段多，而是每个场景在依附哪个教育单元。如果一个场景对某一学段和某一学科的依赖特别高，就说明它还处在强绑定阶段；只有这种依赖逐步下降，这个场景才可能真正泛化。</a:t>
             </a:r>
           </a:p>
         </p:txBody>
@@ -581,7 +581,7 @@
           <a:lstStyle/>
           <a:p>
             <a:r>
-              <a:t>最后这一页要强调，产品竞争已经不只是总量竞争，而是场景控制力竞争。目前最强的单点控制关系出现在 助研 场景中的 国家智慧教育平台。谁能先在具体场景里形成高占比、强替代性，谁就更有机会从工具走向教育基础设施。</a:t>
+              <a:t>最后这一页要讲的不是品牌热度，而是控制力分化。目前最强单点关系出现在 助研 场景中的 国家智慧教育平台，占比约 100%；但 助学 这样的场景头部占比只有约 37%，仍是开放竞争。这意味着真正的胜负手不是谁更红，而是谁先在关键教育场景中形成不可替代的位置。</a:t>
             </a:r>
           </a:p>
         </p:txBody>
@@ -651,7 +651,7 @@
           <a:lstStyle/>
           <a:p>
             <a:r>
-              <a:t>最后落到行动判断。接下来不应继续只看案例数增长，而要看非助学场景是否继续扩张、后发地区是否完成结构升级、以及头部产品是否在具体场景里形成稳定控制力。</a:t>
+              <a:t>最后要把判断收住。接下来不应再只看案例数增长，而要看三件事：主航道之外的新场景能否继续抬升，中西部能否从导入走向稳定的平台化与生态化，以及头部产品能否在关键教育场景中建立长期控制力。</a:t>
             </a:r>
           </a:p>
         </p:txBody>
@@ -855,7 +855,7 @@
           <a:p>
             <a:fld id="{5BCAD085-E8A6-8845-BD4E-CB4CCA059FC4}" type="datetimeFigureOut">
               <a:rPr lang="en-US" smtClean="0"/>
-              <a:t>3/12/26</a:t>
+              <a:t>3/13/26</a:t>
             </a:fld>
             <a:endParaRPr lang="en-US"/>
           </a:p>
@@ -1023,7 +1023,7 @@
           <a:p>
             <a:fld id="{5BCAD085-E8A6-8845-BD4E-CB4CCA059FC4}" type="datetimeFigureOut">
               <a:rPr lang="en-US" smtClean="0"/>
-              <a:t>3/12/26</a:t>
+              <a:t>3/13/26</a:t>
             </a:fld>
             <a:endParaRPr lang="en-US"/>
           </a:p>
@@ -1201,7 +1201,7 @@
           <a:p>
             <a:fld id="{5BCAD085-E8A6-8845-BD4E-CB4CCA059FC4}" type="datetimeFigureOut">
               <a:rPr lang="en-US" smtClean="0"/>
-              <a:t>3/12/26</a:t>
+              <a:t>3/13/26</a:t>
             </a:fld>
             <a:endParaRPr lang="en-US"/>
           </a:p>
@@ -1369,7 +1369,7 @@
           <a:p>
             <a:fld id="{5BCAD085-E8A6-8845-BD4E-CB4CCA059FC4}" type="datetimeFigureOut">
               <a:rPr lang="en-US" smtClean="0"/>
-              <a:t>3/12/26</a:t>
+              <a:t>3/13/26</a:t>
             </a:fld>
             <a:endParaRPr lang="en-US"/>
           </a:p>
@@ -1614,7 +1614,7 @@
           <a:p>
             <a:fld id="{5BCAD085-E8A6-8845-BD4E-CB4CCA059FC4}" type="datetimeFigureOut">
               <a:rPr lang="en-US" smtClean="0"/>
-              <a:t>3/12/26</a:t>
+              <a:t>3/13/26</a:t>
             </a:fld>
             <a:endParaRPr lang="en-US"/>
           </a:p>
@@ -1899,7 +1899,7 @@
           <a:p>
             <a:fld id="{5BCAD085-E8A6-8845-BD4E-CB4CCA059FC4}" type="datetimeFigureOut">
               <a:rPr lang="en-US" smtClean="0"/>
-              <a:t>3/12/26</a:t>
+              <a:t>3/13/26</a:t>
             </a:fld>
             <a:endParaRPr lang="en-US"/>
           </a:p>
@@ -2318,7 +2318,7 @@
           <a:p>
             <a:fld id="{5BCAD085-E8A6-8845-BD4E-CB4CCA059FC4}" type="datetimeFigureOut">
               <a:rPr lang="en-US" smtClean="0"/>
-              <a:t>3/12/26</a:t>
+              <a:t>3/13/26</a:t>
             </a:fld>
             <a:endParaRPr lang="en-US"/>
           </a:p>
@@ -2435,7 +2435,7 @@
           <a:p>
             <a:fld id="{5BCAD085-E8A6-8845-BD4E-CB4CCA059FC4}" type="datetimeFigureOut">
               <a:rPr lang="en-US" smtClean="0"/>
-              <a:t>3/12/26</a:t>
+              <a:t>3/13/26</a:t>
             </a:fld>
             <a:endParaRPr lang="en-US"/>
           </a:p>
@@ -2530,7 +2530,7 @@
           <a:p>
             <a:fld id="{5BCAD085-E8A6-8845-BD4E-CB4CCA059FC4}" type="datetimeFigureOut">
               <a:rPr lang="en-US" smtClean="0"/>
-              <a:t>3/12/26</a:t>
+              <a:t>3/13/26</a:t>
             </a:fld>
             <a:endParaRPr lang="en-US"/>
           </a:p>
@@ -2805,7 +2805,7 @@
           <a:p>
             <a:fld id="{5BCAD085-E8A6-8845-BD4E-CB4CCA059FC4}" type="datetimeFigureOut">
               <a:rPr lang="en-US" smtClean="0"/>
-              <a:t>3/12/26</a:t>
+              <a:t>3/13/26</a:t>
             </a:fld>
             <a:endParaRPr lang="en-US"/>
           </a:p>
@@ -3057,7 +3057,7 @@
           <a:p>
             <a:fld id="{5BCAD085-E8A6-8845-BD4E-CB4CCA059FC4}" type="datetimeFigureOut">
               <a:rPr lang="en-US" smtClean="0"/>
-              <a:t>3/12/26</a:t>
+              <a:t>3/13/26</a:t>
             </a:fld>
             <a:endParaRPr lang="en-US"/>
           </a:p>
@@ -3268,7 +3268,7 @@
           <a:p>
             <a:fld id="{5BCAD085-E8A6-8845-BD4E-CB4CCA059FC4}" type="datetimeFigureOut">
               <a:rPr lang="en-US" smtClean="0"/>
-              <a:t>3/12/26</a:t>
+              <a:t>3/13/26</a:t>
             </a:fld>
             <a:endParaRPr lang="en-US"/>
           </a:p>
@@ -3651,7 +3651,7 @@
         </p:nvSpPr>
         <p:spPr>
           <a:xfrm>
-            <a:off x="0" y="0"/>
+            <a:off x="0" y="312234"/>
             <a:ext cx="12191695" cy="6858000"/>
           </a:xfrm>
           <a:prstGeom prst="rect">
@@ -3754,7 +3754,7 @@
               </a:defRPr>
             </a:pPr>
             <a:r>
-              <a:t>旧版正文风格更新到 V6 口径，并补充结构分化与产品控制力洞见</a:t>
+              <a:t>当前 Word 2.2 结论同步升级为公开宣讲版：观点更锋利，证据更集中，落点更适合大型场合表达</a:t>
             </a:r>
           </a:p>
         </p:txBody>
@@ -3768,7 +3768,7 @@
         <p:spPr>
           <a:xfrm>
             <a:off x="658368" y="1737360"/>
-            <a:ext cx="1828800" cy="1005840"/>
+            <a:ext cx="1170432" cy="1005840"/>
           </a:xfrm>
           <a:prstGeom prst="roundRect">
             <a:avLst/>
@@ -3885,8 +3885,8 @@
         </p:nvSpPr>
         <p:spPr>
           <a:xfrm>
-            <a:off x="2651760" y="1737360"/>
-            <a:ext cx="1828800" cy="1005840"/>
+            <a:off x="1982689" y="1737360"/>
+            <a:ext cx="1170432" cy="1005840"/>
           </a:xfrm>
           <a:prstGeom prst="roundRect">
             <a:avLst/>
@@ -3931,7 +3931,7 @@
         </p:nvSpPr>
         <p:spPr>
           <a:xfrm>
-            <a:off x="2798064" y="1883664"/>
+            <a:off x="2128993" y="1883664"/>
             <a:ext cx="1536192" cy="256032"/>
           </a:xfrm>
           <a:prstGeom prst="rect">
@@ -3941,7 +3941,7 @@
         </p:spPr>
         <p:txBody>
           <a:bodyPr wrap="square">
-            <a:normAutofit/>
+            <a:normAutofit lnSpcReduction="10000"/>
           </a:bodyPr>
           <a:lstStyle/>
           <a:p>
@@ -3967,7 +3967,7 @@
         </p:nvSpPr>
         <p:spPr>
           <a:xfrm>
-            <a:off x="2798064" y="2148840"/>
+            <a:off x="2128993" y="2148840"/>
             <a:ext cx="1536192" cy="384048"/>
           </a:xfrm>
           <a:prstGeom prst="rect">
@@ -3977,7 +3977,7 @@
         </p:spPr>
         <p:txBody>
           <a:bodyPr wrap="square">
-            <a:normAutofit/>
+            <a:normAutofit fontScale="92500" lnSpcReduction="10000"/>
           </a:bodyPr>
           <a:lstStyle/>
           <a:p>
@@ -4003,8 +4003,8 @@
         </p:nvSpPr>
         <p:spPr>
           <a:xfrm>
-            <a:off x="4645152" y="1737360"/>
-            <a:ext cx="1828800" cy="1005840"/>
+            <a:off x="3307013" y="1737360"/>
+            <a:ext cx="1253843" cy="1005840"/>
           </a:xfrm>
           <a:prstGeom prst="roundRect">
             <a:avLst/>
@@ -4049,7 +4049,7 @@
         </p:nvSpPr>
         <p:spPr>
           <a:xfrm>
-            <a:off x="4791456" y="1883664"/>
+            <a:off x="3453317" y="1883664"/>
             <a:ext cx="1536192" cy="256032"/>
           </a:xfrm>
           <a:prstGeom prst="rect">
@@ -4059,7 +4059,7 @@
         </p:spPr>
         <p:txBody>
           <a:bodyPr wrap="square">
-            <a:normAutofit/>
+            <a:normAutofit lnSpcReduction="10000"/>
           </a:bodyPr>
           <a:lstStyle/>
           <a:p>
@@ -4085,7 +4085,7 @@
         </p:nvSpPr>
         <p:spPr>
           <a:xfrm>
-            <a:off x="4791456" y="2148840"/>
+            <a:off x="3453317" y="2148840"/>
             <a:ext cx="1536192" cy="384048"/>
           </a:xfrm>
           <a:prstGeom prst="rect">
@@ -4095,7 +4095,7 @@
         </p:spPr>
         <p:txBody>
           <a:bodyPr wrap="square">
-            <a:normAutofit/>
+            <a:normAutofit fontScale="92500" lnSpcReduction="10000"/>
           </a:bodyPr>
           <a:lstStyle/>
           <a:p>
@@ -4121,8 +4121,8 @@
         </p:nvSpPr>
         <p:spPr>
           <a:xfrm>
-            <a:off x="6638544" y="1737360"/>
-            <a:ext cx="1828800" cy="1005840"/>
+            <a:off x="4687084" y="1737360"/>
+            <a:ext cx="1253843" cy="1005840"/>
           </a:xfrm>
           <a:prstGeom prst="roundRect">
             <a:avLst/>
@@ -4167,8 +4167,8 @@
         </p:nvSpPr>
         <p:spPr>
           <a:xfrm>
-            <a:off x="6784848" y="1883664"/>
-            <a:ext cx="1536192" cy="256032"/>
+            <a:off x="4833388" y="1883664"/>
+            <a:ext cx="1053228" cy="256032"/>
           </a:xfrm>
           <a:prstGeom prst="rect">
             <a:avLst/>
@@ -4177,7 +4177,7 @@
         </p:spPr>
         <p:txBody>
           <a:bodyPr wrap="square">
-            <a:normAutofit/>
+            <a:normAutofit lnSpcReduction="10000"/>
           </a:bodyPr>
           <a:lstStyle/>
           <a:p>
@@ -4203,7 +4203,7 @@
         </p:nvSpPr>
         <p:spPr>
           <a:xfrm>
-            <a:off x="6784848" y="2148840"/>
+            <a:off x="4833388" y="2148840"/>
             <a:ext cx="1536192" cy="384048"/>
           </a:xfrm>
           <a:prstGeom prst="rect">
@@ -4213,7 +4213,7 @@
         </p:spPr>
         <p:txBody>
           <a:bodyPr wrap="square">
-            <a:normAutofit/>
+            <a:normAutofit fontScale="92500" lnSpcReduction="10000"/>
           </a:bodyPr>
           <a:lstStyle/>
           <a:p>
@@ -4240,7 +4240,7 @@
         <p:spPr>
           <a:xfrm>
             <a:off x="658368" y="3054096"/>
-            <a:ext cx="6355080" cy="2633472"/>
+            <a:ext cx="6043515" cy="2633472"/>
           </a:xfrm>
           <a:prstGeom prst="roundRect">
             <a:avLst/>
@@ -4285,8 +4285,8 @@
         </p:nvSpPr>
         <p:spPr>
           <a:xfrm>
-            <a:off x="914400" y="3328416"/>
-            <a:ext cx="5669280" cy="1645920"/>
+            <a:off x="847494" y="3506834"/>
+            <a:ext cx="5669280" cy="1737360"/>
           </a:xfrm>
           <a:prstGeom prst="rect">
             <a:avLst/>
@@ -4295,12 +4295,12 @@
         </p:spPr>
         <p:txBody>
           <a:bodyPr wrap="square">
-            <a:normAutofit/>
+            <a:normAutofit fontScale="92500" lnSpcReduction="20000"/>
           </a:bodyPr>
           <a:lstStyle/>
           <a:p>
             <a:pPr algn="l">
-              <a:defRPr sz="1800" b="0">
+              <a:defRPr sz="1700" b="0">
                 <a:solidFill>
                   <a:srgbClr val="142A38"/>
                 </a:solidFill>
@@ -4308,23 +4308,101 @@
               </a:defRPr>
             </a:pPr>
             <a:r>
-              <a:t>这份汇报不再重复总量结论，而是回答三个更关键的问题：</a:t>
-            </a:r>
-            <a:br/>
-            <a:r>
-              <a:t>1. 六大场景是不是已经进入结构分化期？</a:t>
-            </a:r>
-            <a:br/>
-            <a:r>
-              <a:t>2. 区域差异到底体现为总量差异，还是场景结构差异？</a:t>
-            </a:r>
-            <a:br/>
-            <a:r>
-              <a:t>3. 哪些产品已经在不同场景中形成控制力？</a:t>
-            </a:r>
-          </a:p>
-        </p:txBody>
-      </p:sp>
+              <a:rPr dirty="0" err="1"/>
+              <a:t>这份汇报要回答的不是“AI</a:t>
+            </a:r>
+            <a:r>
+              <a:rPr dirty="0"/>
+              <a:t> </a:t>
+            </a:r>
+            <a:r>
+              <a:rPr dirty="0" err="1"/>
+              <a:t>有没有进校园</a:t>
+            </a:r>
+            <a:r>
+              <a:rPr dirty="0"/>
+              <a:t>”，</a:t>
+            </a:r>
+            <a:r>
+              <a:rPr dirty="0" err="1"/>
+              <a:t>而是三件更重要的事</a:t>
+            </a:r>
+            <a:r>
+              <a:rPr dirty="0"/>
+              <a:t>：</a:t>
+            </a:r>
+            <a:br>
+              <a:rPr dirty="0"/>
+            </a:br>
+            <a:r>
+              <a:rPr dirty="0"/>
+              <a:t>1. </a:t>
+            </a:r>
+            <a:r>
+              <a:rPr dirty="0" err="1"/>
+              <a:t>为什么七成以上案例仍集中在助学，但我们已经不能只讲助学</a:t>
+            </a:r>
+            <a:r>
+              <a:rPr dirty="0"/>
+              <a:t>？</a:t>
+            </a:r>
+            <a:br>
+              <a:rPr dirty="0"/>
+            </a:br>
+            <a:r>
+              <a:rPr dirty="0"/>
+              <a:t>2. </a:t>
+            </a:r>
+            <a:r>
+              <a:rPr dirty="0" err="1"/>
+              <a:t>为什么区域差异的本质，不是有没有接入，而是谁先形成了稳定的产品组合</a:t>
+            </a:r>
+            <a:r>
+              <a:rPr dirty="0"/>
+              <a:t>？</a:t>
+            </a:r>
+            <a:br>
+              <a:rPr dirty="0"/>
+            </a:br>
+            <a:r>
+              <a:rPr dirty="0"/>
+              <a:t>3. </a:t>
+            </a:r>
+            <a:r>
+              <a:rPr dirty="0" err="1"/>
+              <a:t>为什么下一阶段真正的竞争，不在模型热度，而在教育场景控制力</a:t>
+            </a:r>
+            <a:r>
+              <a:rPr dirty="0"/>
+              <a:t>？</a:t>
+            </a:r>
+          </a:p>
+        </p:txBody>
+      </p:sp>
+      <p:pic>
+        <p:nvPicPr>
+          <p:cNvPr id="19" name="Picture 18" descr="fig_a04_scenario_treemap.png"/>
+          <p:cNvPicPr>
+            <a:picLocks noChangeAspect="1"/>
+          </p:cNvPicPr>
+          <p:nvPr/>
+        </p:nvPicPr>
+        <p:blipFill>
+          <a:blip r:embed="rId3"/>
+          <a:stretch>
+            <a:fillRect/>
+          </a:stretch>
+        </p:blipFill>
+        <p:spPr>
+          <a:xfrm>
+            <a:off x="6848187" y="1639035"/>
+            <a:ext cx="5113131" cy="4204397"/>
+          </a:xfrm>
+          <a:prstGeom prst="rect">
+            <a:avLst/>
+          </a:prstGeom>
+        </p:spPr>
+      </p:pic>
     </p:spTree>
   </p:cSld>
   <p:clrMapOvr>
@@ -4403,7 +4481,7 @@
         <p:spPr>
           <a:xfrm>
             <a:off x="621792" y="365760"/>
-            <a:ext cx="7315200" cy="457200"/>
+            <a:ext cx="7680960" cy="457200"/>
           </a:xfrm>
           <a:prstGeom prst="rect">
             <a:avLst/>
@@ -4425,7 +4503,7 @@
               </a:defRPr>
             </a:pPr>
             <a:r>
-              <a:t>一、六大场景已经进入“扩散广度 × 教学复杂度”分化期</a:t>
+              <a:t>一、真正的变化不是场景变多，而是主航道已经收敛出来</a:t>
             </a:r>
           </a:p>
         </p:txBody>
@@ -4590,8 +4668,8 @@
         </p:nvSpPr>
         <p:spPr>
           <a:xfrm>
-            <a:off x="7717536" y="1536192"/>
-            <a:ext cx="3520440" cy="1371600"/>
+            <a:off x="7717536" y="1481328"/>
+            <a:ext cx="3520440" cy="1600200"/>
           </a:xfrm>
           <a:prstGeom prst="rect">
             <a:avLst/>
@@ -4605,7 +4683,7 @@
           <a:lstStyle/>
           <a:p>
             <a:pPr algn="l">
-              <a:defRPr sz="1700" b="0">
+              <a:defRPr sz="1600" b="0">
                 <a:solidFill>
                   <a:srgbClr val="142A38"/>
                 </a:solidFill>
@@ -4613,7 +4691,7 @@
               </a:defRPr>
             </a:pPr>
             <a:r>
-              <a:t>助学仍然保持最大规模，当前达到 1215 例，但它已经不是唯一增长方向。助教、助评和助育虽然体量较小，却明显向更高复杂度任务延伸。</a:t>
+              <a:t>助学单一场景就占到 72.1%，而助学+助教合计达到 90.0%。这说明行业已经不是“六路并进”，而是从泛试点走向主航道收敛。</a:t>
             </a:r>
           </a:p>
         </p:txBody>
@@ -4626,8 +4704,8 @@
         </p:nvSpPr>
         <p:spPr>
           <a:xfrm>
-            <a:off x="7717536" y="3182112"/>
-            <a:ext cx="3383280" cy="2194560"/>
+            <a:off x="7717536" y="3310128"/>
+            <a:ext cx="3383280" cy="1874519"/>
           </a:xfrm>
           <a:prstGeom prst="rect">
             <a:avLst/>
@@ -4641,7 +4719,7 @@
           <a:lstStyle/>
           <a:p>
             <a:pPr algn="l">
-              <a:defRPr sz="1700" b="0">
+              <a:defRPr sz="1600" b="0">
                 <a:solidFill>
                   <a:srgbClr val="142A38"/>
                 </a:solidFill>
@@ -4649,7 +4727,7 @@
               </a:defRPr>
             </a:pPr>
             <a:r>
-              <a:t>最值得关注的是右上象限：如果某一场景同时具备更高的省份覆盖和学科覆盖，就说明它不仅能做，而且开始在不同教育单元中可复制。当前最接近这一状态的，已经不只是 助学。</a:t>
+              <a:t>但收敛不等于单一。助教、助评、助育虽然体量小，却在省份覆盖与学科覆盖上持续抬升，意味着更高复杂度的教学系统场景正在进入可复制阶段。</a:t>
             </a:r>
           </a:p>
         </p:txBody>
@@ -4732,7 +4810,7 @@
         <p:spPr>
           <a:xfrm>
             <a:off x="621792" y="365760"/>
-            <a:ext cx="7132320" cy="457200"/>
+            <a:ext cx="10881360" cy="457200"/>
           </a:xfrm>
           <a:prstGeom prst="rect">
             <a:avLst/>
@@ -4754,7 +4832,12 @@
               </a:defRPr>
             </a:pPr>
             <a:r>
-              <a:t>二、区域差异正在从“有没有”转向“结构长什么样”</a:t>
+              <a:rPr dirty="0" err="1"/>
+              <a:t>二、区域空间格局已经呈现“东部生态化、中部平台化、西部导入期</a:t>
+            </a:r>
+            <a:r>
+              <a:rPr dirty="0"/>
+              <a:t>”</a:t>
             </a:r>
           </a:p>
         </p:txBody>
@@ -4768,7 +4851,7 @@
         <p:spPr>
           <a:xfrm>
             <a:off x="640080" y="841248"/>
-            <a:ext cx="7498079" cy="292608"/>
+            <a:ext cx="8595360" cy="292608"/>
           </a:xfrm>
           <a:prstGeom prst="rect">
             <a:avLst/>
@@ -4790,21 +4873,69 @@
               </a:defRPr>
             </a:pPr>
             <a:r>
-              <a:t>把每个区域内部标准化到 100%，就能看清场景结构而不仅是总量大小</a:t>
-            </a:r>
-          </a:p>
-        </p:txBody>
-      </p:sp>
-      <p:sp>
-        <p:nvSpPr>
-          <p:cNvPr id="5" name="Rounded Rectangle 4"/>
+              <a:t>直接复用 Word 2.2.2 的当前论证链：省域分布地图负责看总量，区域×产品热力图负责看组合结构</a:t>
+            </a:r>
+          </a:p>
+        </p:txBody>
+      </p:sp>
+      <p:pic>
+        <p:nvPicPr>
+          <p:cNvPr id="6" name="Picture 5" descr="fig_a01_province_map.png"/>
+          <p:cNvPicPr>
+            <a:picLocks noChangeAspect="1"/>
+          </p:cNvPicPr>
+          <p:nvPr/>
+        </p:nvPicPr>
+        <p:blipFill>
+          <a:blip r:embed="rId3"/>
+          <a:stretch>
+            <a:fillRect/>
+          </a:stretch>
+        </p:blipFill>
+        <p:spPr>
+          <a:xfrm>
+            <a:off x="777240" y="1268396"/>
+            <a:ext cx="5029200" cy="4915567"/>
+          </a:xfrm>
+          <a:prstGeom prst="rect">
+            <a:avLst/>
+          </a:prstGeom>
+        </p:spPr>
+      </p:pic>
+      <p:pic>
+        <p:nvPicPr>
+          <p:cNvPr id="8" name="Picture 7" descr="fig_a06_region_product.png"/>
+          <p:cNvPicPr>
+            <a:picLocks noChangeAspect="1"/>
+          </p:cNvPicPr>
+          <p:nvPr/>
+        </p:nvPicPr>
+        <p:blipFill>
+          <a:blip r:embed="rId4"/>
+          <a:stretch>
+            <a:fillRect/>
+          </a:stretch>
+        </p:blipFill>
+        <p:spPr>
+          <a:xfrm>
+            <a:off x="649224" y="5184648"/>
+            <a:ext cx="5029200" cy="2112264"/>
+          </a:xfrm>
+          <a:prstGeom prst="rect">
+            <a:avLst/>
+          </a:prstGeom>
+        </p:spPr>
+      </p:pic>
+      <p:sp>
+        <p:nvSpPr>
+          <p:cNvPr id="9" name="Rounded Rectangle 8"/>
           <p:cNvSpPr/>
           <p:nvPr/>
         </p:nvSpPr>
         <p:spPr>
           <a:xfrm>
-            <a:off x="585216" y="1207008"/>
-            <a:ext cx="6720840" cy="5074920"/>
+            <a:off x="6327648" y="1188720"/>
+            <a:ext cx="5175504" cy="5074920"/>
           </a:xfrm>
           <a:prstGeom prst="roundRect">
             <a:avLst/>
@@ -4841,86 +4972,16 @@
           </a:p>
         </p:txBody>
       </p:sp>
-      <p:pic>
-        <p:nvPicPr>
-          <p:cNvPr id="6" name="Picture 5" descr="fig_ppt_region_structure.png"/>
-          <p:cNvPicPr>
-            <a:picLocks noChangeAspect="1"/>
-          </p:cNvPicPr>
-          <p:nvPr/>
-        </p:nvPicPr>
-        <p:blipFill>
-          <a:blip r:embed="rId3"/>
-          <a:stretch>
-            <a:fillRect/>
-          </a:stretch>
-        </p:blipFill>
-        <p:spPr>
-          <a:xfrm>
-            <a:off x="804672" y="1444752"/>
-            <a:ext cx="6309360" cy="3483292"/>
-          </a:xfrm>
-          <a:prstGeom prst="rect">
-            <a:avLst/>
-          </a:prstGeom>
-        </p:spPr>
-      </p:pic>
-      <p:sp>
-        <p:nvSpPr>
-          <p:cNvPr id="7" name="Rounded Rectangle 6"/>
-          <p:cNvSpPr/>
-          <p:nvPr/>
-        </p:nvSpPr>
-        <p:spPr>
-          <a:xfrm>
-            <a:off x="7498079" y="1207008"/>
-            <a:ext cx="4005072" cy="5074920"/>
-          </a:xfrm>
-          <a:prstGeom prst="roundRect">
-            <a:avLst/>
-          </a:prstGeom>
-          <a:solidFill>
-            <a:srgbClr val="FFFCF7"/>
-          </a:solidFill>
-          <a:ln w="12700">
-            <a:solidFill>
-              <a:srgbClr val="E1D8CB"/>
-            </a:solidFill>
-          </a:ln>
-        </p:spPr>
-        <p:style>
-          <a:lnRef idx="1">
-            <a:schemeClr val="accent1"/>
-          </a:lnRef>
-          <a:fillRef idx="3">
-            <a:schemeClr val="accent1"/>
-          </a:fillRef>
-          <a:effectRef idx="2">
-            <a:schemeClr val="accent1"/>
-          </a:effectRef>
-          <a:fontRef idx="minor">
-            <a:schemeClr val="lt1"/>
-          </a:fontRef>
-        </p:style>
-        <p:txBody>
-          <a:bodyPr rtlCol="0" anchor="ctr"/>
-          <a:lstStyle/>
-          <a:p>
-            <a:pPr algn="ctr"/>
-            <a:endParaRPr/>
-          </a:p>
-        </p:txBody>
-      </p:sp>
-      <p:sp>
-        <p:nvSpPr>
-          <p:cNvPr id="8" name="TextBox 7"/>
+      <p:sp>
+        <p:nvSpPr>
+          <p:cNvPr id="11" name="TextBox 10"/>
           <p:cNvSpPr txBox="1"/>
           <p:nvPr/>
         </p:nvSpPr>
         <p:spPr>
           <a:xfrm>
-            <a:off x="7754112" y="1572768"/>
-            <a:ext cx="3456432" cy="1371600"/>
+            <a:off x="6601968" y="2121408"/>
+            <a:ext cx="4572000" cy="1078992"/>
           </a:xfrm>
           <a:prstGeom prst="rect">
             <a:avLst/>
@@ -4934,7 +4995,7 @@
           <a:lstStyle/>
           <a:p>
             <a:pPr algn="l">
-              <a:defRPr sz="1700" b="0">
+              <a:defRPr sz="1500" b="0">
                 <a:solidFill>
                   <a:srgbClr val="142A38"/>
                 </a:solidFill>
@@ -4942,21 +5003,21 @@
               </a:defRPr>
             </a:pPr>
             <a:r>
-              <a:t>东部依然是绝对主集聚区，但更重要的是，它在助教、助评、助育这些非助学场景中的占比更高，说明它已经开始从规模领先切向结构领先。</a:t>
-            </a:r>
-          </a:p>
-        </p:txBody>
-      </p:sp>
-      <p:sp>
-        <p:nvSpPr>
-          <p:cNvPr id="9" name="TextBox 8"/>
+              <a:t>1. 头部板块已经非常集中。浙江省、四川省、重庆市和北京市四省市合计占全部案例的54.1%，这意味着全国应用并不是均匀铺开，而是由少数头部区域牵引。</a:t>
+            </a:r>
+          </a:p>
+        </p:txBody>
+      </p:sp>
+      <p:sp>
+        <p:nvSpPr>
+          <p:cNvPr id="12" name="TextBox 11"/>
           <p:cNvSpPr txBox="1"/>
           <p:nvPr/>
         </p:nvSpPr>
         <p:spPr>
           <a:xfrm>
-            <a:off x="7754112" y="3246120"/>
-            <a:ext cx="3456432" cy="1783080"/>
+            <a:off x="6601968" y="3438144"/>
+            <a:ext cx="4572000" cy="932688"/>
           </a:xfrm>
           <a:prstGeom prst="rect">
             <a:avLst/>
@@ -4970,7 +5031,7 @@
           <a:lstStyle/>
           <a:p>
             <a:pPr algn="l">
-              <a:defRPr sz="1700" b="0">
+              <a:defRPr sz="1500" b="0">
                 <a:solidFill>
                   <a:srgbClr val="142A38"/>
                 </a:solidFill>
@@ -4978,7 +5039,43 @@
               </a:defRPr>
             </a:pPr>
             <a:r>
-              <a:t>中西部并非没有 AI，而是更集中在可快速落地、低门槛的场景。换句话说，后发地区当前最显著的任务不是扩大总量，而是推进场景结构升级。</a:t>
+              <a:t>2. 东部的领先不是“多一点”，而是已经进入生态化组合。东部样本 1004 例，且豆包（250次）、DeepSeek 大模型（179次）、即梦AI（103次）三者就构成了78.1%的头部产品集中度。</a:t>
+            </a:r>
+          </a:p>
+        </p:txBody>
+      </p:sp>
+      <p:sp>
+        <p:nvSpPr>
+          <p:cNvPr id="13" name="TextBox 12"/>
+          <p:cNvSpPr txBox="1"/>
+          <p:nvPr/>
+        </p:nvSpPr>
+        <p:spPr>
+          <a:xfrm>
+            <a:off x="6601968" y="4572000"/>
+            <a:ext cx="4572000" cy="1225296"/>
+          </a:xfrm>
+          <a:prstGeom prst="rect">
+            <a:avLst/>
+          </a:prstGeom>
+          <a:noFill/>
+        </p:spPr>
+        <p:txBody>
+          <a:bodyPr wrap="square">
+            <a:normAutofit/>
+          </a:bodyPr>
+          <a:lstStyle/>
+          <a:p>
+            <a:pPr algn="l">
+              <a:defRPr sz="1500" b="0">
+                <a:solidFill>
+                  <a:srgbClr val="142A38"/>
+                </a:solidFill>
+                <a:latin typeface="PingFang SC"/>
+              </a:defRPr>
+            </a:pPr>
+            <a:r>
+              <a:t>3. 中西部的差别也很清楚。中部更像平台化稳步推进，豆包（51次）、DeepSeek 大模型（25次）、即梦AI（18次）三者集中度为71.2%；西部则更像头部产品导入期，豆包（117次）、DeepSeek 大模型（87次）、即梦AI（54次）三者集中度达到73.9%。</a:t>
             </a:r>
           </a:p>
         </p:txBody>
@@ -5061,7 +5158,7 @@
         <p:spPr>
           <a:xfrm>
             <a:off x="621792" y="365760"/>
-            <a:ext cx="7315200" cy="457200"/>
+            <a:ext cx="7863840" cy="457200"/>
           </a:xfrm>
           <a:prstGeom prst="rect">
             <a:avLst/>
@@ -5083,7 +5180,7 @@
               </a:defRPr>
             </a:pPr>
             <a:r>
-              <a:t>三、不同场景并不是均匀落地，而是各自依附不同教育单元</a:t>
+              <a:t>三、场景不是平均落地，而是深度绑定不同教育单元</a:t>
             </a:r>
           </a:p>
         </p:txBody>
@@ -5186,7 +5283,7 @@
         </p:blipFill>
         <p:spPr>
           <a:xfrm>
-            <a:off x="786384" y="1426464"/>
+            <a:off x="963168" y="1905069"/>
             <a:ext cx="5522976" cy="3326338"/>
           </a:xfrm>
           <a:prstGeom prst="rect">
@@ -5271,19 +5368,19 @@
               </a:defRPr>
             </a:pPr>
             <a:r>
-              <a:t>助学：最集中学段为小学，最集中学科为语文</a:t>
+              <a:t>助学：小学占55%，语文占17%</a:t>
             </a:r>
             <a:br/>
             <a:r>
-              <a:t>助教：最集中学段为小学，最集中学科为未提及</a:t>
+              <a:t>助教：小学占45%，未提及占39%</a:t>
             </a:r>
             <a:br/>
             <a:r>
-              <a:t>助评：最集中学段为小学，最集中学科为未提及</a:t>
+              <a:t>助评：小学占68%，未提及占62%</a:t>
             </a:r>
             <a:br/>
             <a:r>
-              <a:t>助育：最集中学段为小学，最集中学科为德育</a:t>
+              <a:t>助育：小学占50%，德育占16%</a:t>
             </a:r>
           </a:p>
         </p:txBody>
@@ -5296,8 +5393,8 @@
         </p:nvSpPr>
         <p:spPr>
           <a:xfrm>
-            <a:off x="7077456" y="5047488"/>
-            <a:ext cx="3931920" cy="868680"/>
+            <a:off x="7077456" y="4919472"/>
+            <a:ext cx="3931920" cy="1005840"/>
           </a:xfrm>
           <a:prstGeom prst="rect">
             <a:avLst/>
@@ -5319,7 +5416,12 @@
               </a:defRPr>
             </a:pPr>
             <a:r>
-              <a:t>同一批产品之所以在不同场景里表现不同，关键不在模型本身，而在它落入了哪一个教育组织单元。</a:t>
+              <a:rPr dirty="0" err="1"/>
+              <a:t>这页真正要讲的是：同一模型进入不同场景后，决定它效果上限的往往不是模型参数，而是它嵌入了哪个教育组织单元</a:t>
+            </a:r>
+            <a:r>
+              <a:rPr dirty="0"/>
+              <a:t>。</a:t>
             </a:r>
           </a:p>
         </p:txBody>
@@ -5402,7 +5504,7 @@
         <p:spPr>
           <a:xfrm>
             <a:off x="621792" y="365760"/>
-            <a:ext cx="7223760" cy="457200"/>
+            <a:ext cx="7498079" cy="457200"/>
           </a:xfrm>
           <a:prstGeom prst="rect">
             <a:avLst/>
@@ -5424,7 +5526,7 @@
               </a:defRPr>
             </a:pPr>
             <a:r>
-              <a:t>四、头部产品已经在不同场景中形成差异化控制力</a:t>
+              <a:t>四、产品竞争已经从“谁更热”升级为“谁能控制关键场景”</a:t>
             </a:r>
           </a:p>
         </p:txBody>
@@ -5527,7 +5629,7 @@
         </p:blipFill>
         <p:spPr>
           <a:xfrm>
-            <a:off x="786384" y="1426464"/>
+            <a:off x="944880" y="2172780"/>
             <a:ext cx="6931152" cy="3024503"/>
           </a:xfrm>
           <a:prstGeom prst="rect">
@@ -5590,7 +5692,7 @@
         <p:spPr>
           <a:xfrm>
             <a:off x="8412480" y="1572768"/>
-            <a:ext cx="2834640" cy="1691640"/>
+            <a:ext cx="2834640" cy="1828800"/>
           </a:xfrm>
           <a:prstGeom prst="rect">
             <a:avLst/>
@@ -5612,7 +5714,7 @@
               </a:defRPr>
             </a:pPr>
             <a:r>
-              <a:t>如果某个产品在某个场景中的占比明显高于其他产品，就说明它不只是高频，而是已经形成场景控制力。当前最强的控制力仍主要出现在助学相关场景。</a:t>
+              <a:t>这一页最重要的不是谁排第一，而是控制力已经开始分层。最强单点仍在助学相关场景，但也有场景的头部占比只有约37%，说明仍处开放竞争状态。</a:t>
             </a:r>
           </a:p>
         </p:txBody>
@@ -5626,7 +5728,7 @@
         <p:spPr>
           <a:xfrm>
             <a:off x="8412480" y="3822191"/>
-            <a:ext cx="2834640" cy="1005840"/>
+            <a:ext cx="2834640" cy="1170432"/>
           </a:xfrm>
           <a:prstGeom prst="rect">
             <a:avLst/>
@@ -5640,7 +5742,7 @@
           <a:lstStyle/>
           <a:p>
             <a:pPr algn="l">
-              <a:defRPr sz="1600" b="1">
+              <a:defRPr sz="1500" b="1">
                 <a:solidFill>
                   <a:srgbClr val="C75C38"/>
                 </a:solidFill>
@@ -5648,7 +5750,15 @@
               </a:defRPr>
             </a:pPr>
             <a:r>
+              <a:rPr dirty="0"/>
               <a:t>最强单点：助研场景中的国家智慧教育平台，场景内占比约100%</a:t>
+            </a:r>
+            <a:br>
+              <a:rPr dirty="0"/>
+            </a:br>
+            <a:r>
+              <a:rPr dirty="0"/>
+              <a:t>最开放场景：助学，头部占比约37%</a:t>
             </a:r>
           </a:p>
         </p:txBody>
@@ -5835,17 +5945,17 @@
               </a:defRPr>
             </a:pPr>
             <a:r>
-              <a:t>1. 从场景看：AI 教育应用已由“助学单核”转向“助学为主、助教助评助育多核起势”。</a:t>
+              <a:t>1. 从场景看：教育 AI 已从泛试点进入主航道收敛阶段，助学与助教构成最清晰的两条主线。</a:t>
             </a:r>
             <a:br/>
             <a:br/>
             <a:r>
-              <a:t>2. 从区域看：真正的差异已经从总量落差转向结构落差，东部领先更多体现为场景组合更丰富。</a:t>
+              <a:t>2. 从区域看：全国格局并非均匀扩散，而是少数头部区域先形成产品组合与应用路径，东部生态化、中部平台化、西部导入期的分层已经出现。</a:t>
             </a:r>
             <a:br/>
             <a:br/>
             <a:r>
-              <a:t>3. 从产品看：头部产品正在争夺具体场景的控制力，未来胜负手不在通用能力，而在教育场景嵌入深度。</a:t>
+              <a:t>3. 从产品看：下一阶段真正决定胜负的，不是模型热度，而是谁能在关键教育场景里形成稳定控制力。</a:t>
             </a:r>
           </a:p>
         </p:txBody>

</xml_diff>